<commit_message>
added analysis outputs, appendix materials, and reproducibility documentation
</commit_message>
<xml_diff>
--- a/03_report/presentation/Poster_BA.pptx
+++ b/03_report/presentation/Poster_BA.pptx
@@ -222,7 +222,7 @@
           <a:p>
             <a:fld id="{8946B381-68CC-451E-A196-85699053D4FD}" type="datetimeFigureOut">
               <a:rPr lang="de-DE" smtClean="0"/>
-              <a:t>03.07.26</a:t>
+              <a:t>15.07.26</a:t>
             </a:fld>
             <a:endParaRPr lang="de-DE"/>
           </a:p>
@@ -6877,7 +6877,7 @@
           <a:p>
             <a:r>
               <a:rPr lang="en-DE" dirty="0"/>
-              <a:t>Einwaldweg 10, 70794 Plattenhardt, Germany</a:t>
+              <a:t>Einwaldweg 10, 70794 Filderstadt, Germany</a:t>
             </a:r>
           </a:p>
           <a:p>
@@ -7124,7 +7124,7 @@
         </p:nvSpPr>
         <p:spPr>
           <a:xfrm>
-            <a:off x="979486" y="6205943"/>
+            <a:off x="979486" y="5852299"/>
             <a:ext cx="6908165" cy="830997"/>
           </a:xfrm>
           <a:prstGeom prst="rect">
@@ -7163,8 +7163,8 @@
         </p:nvSpPr>
         <p:spPr>
           <a:xfrm>
-            <a:off x="979486" y="7221606"/>
-            <a:ext cx="28765418" cy="2769989"/>
+            <a:off x="979486" y="6817162"/>
+            <a:ext cx="28765418" cy="3231654"/>
           </a:xfrm>
           <a:prstGeom prst="rect">
             <a:avLst/>
@@ -7186,7 +7186,7 @@
                   </a:schemeClr>
                 </a:solidFill>
               </a:rPr>
-              <a:t>Complex knowledge-work decisions often require several actors to combine specialised and partly distributed information. LLM-based multi-agent systems can support such tasks by assigning different roles and information profiles to several agents. However, the presence of multiple agents does not automatically ensure effective collaboration: agents must retain relevant knowledge, exchange private information, and integrate one another’s contributions over several discussion turns. Drawing on shared mental model theory from human-team research, this study examines whether a structured memory mechanism can provide agents with a more coherent representation of the evolving group knowledge state. It further investigates whether the usefulness of this mechanism depends on how much prior discussion context is accessible to the agents.</a:t>
+              <a:t>Collective decision making in distributed tasks depends on whether team members disclose and integrate knowledge distributed across the team. This challenge is central to complex knowledge work. LLM-based multi-agent systems (MAS) offer a computational approach to such tasks by giving agents distinct roles and information profiles. However, the mere presence of multiple agents does not guarantee effective and efficient collaboration. Agents must disclose privately held knowledge, retain relevant contributions, and integrate them into a coherent representation of the evolving task. Human team research explains such coordination through shared mental models (SMMs), which provide members with sufficiently compatible understandings of the task, the team, and their interaction. Translating this idea into a computational design mechanism, this study investigates whether a SMM-inspired structured memory improves the efficiency and effectiveness of LLM-based MAS, and how its effects depend on the amount of prior discussion history available to agents.</a:t>
             </a:r>
             <a:endParaRPr lang="en-DE" sz="3000" dirty="0">
               <a:solidFill>
@@ -7252,7 +7252,7 @@
         <p:spPr>
           <a:xfrm>
             <a:off x="979486" y="11129354"/>
-            <a:ext cx="13250069" cy="10156627"/>
+            <a:ext cx="13250069" cy="9694962"/>
           </a:xfrm>
           <a:prstGeom prst="rect">
             <a:avLst/>
@@ -7274,7 +7274,7 @@
                   </a:schemeClr>
                 </a:solidFill>
               </a:rPr>
-              <a:t>The input–process–outcome framework explains team performance by distinguishing between the resources and conditions available to a team, the processes through which members combine these resources, and the outcomes that result from their collective work. A central input in human-team research is the shared mental model: a compatible understanding of the task, the team, and the evolving knowledge state. Such shared representations support communication and cooperation by helping team members identify available information, relate others’ contributions to the collective task, and recognise unresolved issues. Through these processes, teams can transform their available knowledge into effective and efficient performance.</a:t>
+              <a:t>Research commonly explains team performance through the input–process–outcome framework. Inputs comprise the resources and conditions available to a team, processes describe how members transform inputs into outputs, and outcomes capture the results of their collective work. One central input factor is the SMM. They provide team members with a sufficiently compatible understanding of the task, the team, and the current situation. This common cognitive basis helps members anticipate what information others need, connect individual contributions to the collective task, and coordinate their actions. Through the I-P-O framework SMM supports two central team processes, communication and cooperation, which in turn shape team performance.</a:t>
             </a:r>
           </a:p>
           <a:p>
@@ -7287,7 +7287,7 @@
                   </a:schemeClr>
                 </a:solidFill>
               </a:rPr>
-              <a:t>LLM-based multi-agent systems face a comparable challenge when specialised agents must combine distributed information to reach a joint decision. Although LLM agents do not possess shared mental models in the psychological sense, their functional role can be translated into an external structured memory mechanism. This mechanism records disclosed facts, candidate evaluations, agent positions, the emerging group view, and unresolved questions, and makes this information available in later discussion turns. Together with the accessible discussion history, it forms the system’s context configuration. This configuration represents the input of the proposed model, communication and cooperation represent the central processes, and weighted token usage and correct decisions represent computational efficiency and decision effectiveness.</a:t>
+              <a:t>LLM-based MAS face an analogous coordination problem when specialised agents must integrate distributed information into a joint decision. To overcome this problem, this study translates the mechanism of SMM into an external structured memory mechanism. It records task-relevant facts, candidate evaluations, individual positions, the emerging group view, and unresolved questions and reintroduces this representation into the agents’ context before subsequent contributions. Its effects may depend on how much of the prior discussion history remains accessible alongside it. This amount is termed discussion-context transparency. Structured memory and discussion-context transparency together define the system’s context configuration.</a:t>
             </a:r>
           </a:p>
         </p:txBody>
@@ -7306,8 +7306,8 @@
         </p:nvSpPr>
         <p:spPr>
           <a:xfrm>
-            <a:off x="14526445" y="21917883"/>
-            <a:ext cx="15218459" cy="4616648"/>
+            <a:off x="14526445" y="20994553"/>
+            <a:ext cx="15218459" cy="5539978"/>
           </a:xfrm>
           <a:prstGeom prst="rect">
             <a:avLst/>
@@ -7329,7 +7329,7 @@
                   </a:schemeClr>
                 </a:solidFill>
               </a:rPr>
-              <a:t>The study comprised 800 independent simulations of a personnel-selection task. Three LLM-based agents acted as an airline hiring panel and selected a long-distance pilot from four candidates. Although all agents received the same task information, each held different private facts; Candidate C could only be identified as the best choice when these facts were shared and integrated. The study compared a transcript-only baseline with three structured-memory conditions offering low, moderate, or high discussion-context transparency. Communication captured whether private information was taken up by another agent, cooperation captured the integration of others’ contributions, and performance was assessed through weighted token usage and correct selection of Candidate C.</a:t>
+              <a:t>The study is based on 800 independent simulations of a hidden-profile personnel-selection task. Three LLM-based agents acted as an airline hiring panel and selected one of four candidates for a long-distance pilot position. According to the hidden profile paradigm, all agents received shared task materials, while also holding private candidate information. Candidate C was the superior choice in the complete information set and could only be identified if agents disclosed and integrated their private facts. The study compared a baseline without a structured memory mechanism with three structured memory conditions that differed in discussion-context transparency: low (only the immediately preceding contribution), moderate (full public discussion history), and high (full public history plus prior reasoning traces). Communication quality, cooperation quality, weighted token usage as proxy for efficiency, and correct selection of Candidate C as proxy for effectiveness were used as outcome measures.</a:t>
             </a:r>
           </a:p>
         </p:txBody>
@@ -7348,7 +7348,7 @@
         </p:nvSpPr>
         <p:spPr>
           <a:xfrm>
-            <a:off x="979486" y="26850440"/>
+            <a:off x="979486" y="26621841"/>
             <a:ext cx="17446626" cy="830997"/>
           </a:xfrm>
           <a:prstGeom prst="rect">
@@ -7373,12 +7373,445 @@
           </a:p>
         </p:txBody>
       </p:sp>
+      <p:sp>
+        <p:nvSpPr>
+          <p:cNvPr id="30" name="TextBox 29">
+            <a:extLst>
+              <a:ext uri="{FF2B5EF4-FFF2-40B4-BE49-F238E27FC236}">
+                <a16:creationId xmlns:a16="http://schemas.microsoft.com/office/drawing/2014/main" id="{A4DAE3DE-44F3-E8CE-612F-BC9D0AFA3EA6}"/>
+              </a:ext>
+            </a:extLst>
+          </p:cNvPr>
+          <p:cNvSpPr txBox="1"/>
+          <p:nvPr/>
+        </p:nvSpPr>
+        <p:spPr>
+          <a:xfrm>
+            <a:off x="14526443" y="19865474"/>
+            <a:ext cx="17446626" cy="830997"/>
+          </a:xfrm>
+          <a:prstGeom prst="rect">
+            <a:avLst/>
+          </a:prstGeom>
+          <a:noFill/>
+        </p:spPr>
+        <p:txBody>
+          <a:bodyPr wrap="square" lIns="0" tIns="0" rIns="0" bIns="0" rtlCol="0">
+            <a:spAutoFit/>
+          </a:bodyPr>
+          <a:lstStyle/>
+          <a:p>
+            <a:r>
+              <a:rPr lang="en-DE" sz="5400" b="1" dirty="0">
+                <a:solidFill>
+                  <a:schemeClr val="tx2"/>
+                </a:solidFill>
+              </a:rPr>
+              <a:t>III. Methodology</a:t>
+            </a:r>
+          </a:p>
+        </p:txBody>
+      </p:sp>
+      <p:sp>
+        <p:nvSpPr>
+          <p:cNvPr id="34" name="TextBox 33">
+            <a:extLst>
+              <a:ext uri="{FF2B5EF4-FFF2-40B4-BE49-F238E27FC236}">
+                <a16:creationId xmlns:a16="http://schemas.microsoft.com/office/drawing/2014/main" id="{BCB0C2AC-AE2B-E4AC-4D1F-9AC9680D5E1B}"/>
+              </a:ext>
+            </a:extLst>
+          </p:cNvPr>
+          <p:cNvSpPr txBox="1"/>
+          <p:nvPr/>
+        </p:nvSpPr>
+        <p:spPr>
+          <a:xfrm>
+            <a:off x="978225" y="27616419"/>
+            <a:ext cx="28765417" cy="4154984"/>
+          </a:xfrm>
+          <a:prstGeom prst="rect">
+            <a:avLst/>
+          </a:prstGeom>
+          <a:noFill/>
+        </p:spPr>
+        <p:txBody>
+          <a:bodyPr wrap="square" lIns="0" tIns="0" rIns="0" bIns="0" rtlCol="0">
+            <a:spAutoFit/>
+          </a:bodyPr>
+          <a:lstStyle/>
+          <a:p>
+            <a:pPr algn="just"/>
+            <a:r>
+              <a:rPr lang="en-GB" sz="3000" dirty="0">
+                <a:solidFill>
+                  <a:schemeClr val="tx1">
+                    <a:lumMod val="75000"/>
+                  </a:schemeClr>
+                </a:solidFill>
+              </a:rPr>
+              <a:t>Three takeaways stand out. First, the SMM-inspired structured memory supports better collective decisions, although this improvement came with greater computational effort and depended on the surrounding context. The strongest outcomes emerged under low discussion-context transparency, where the structured representation was accompanied by only limited raw discussion history. Second, more context is not necessarily better. High transparency increased token usage and was associated with lower decision effectiveness, suggesting that extensive discussion history can reduce the salience of relevant information. Third, communication and </a:t>
+            </a:r>
+            <a:r>
+              <a:rPr lang="en-GB" sz="3000">
+                <a:solidFill>
+                  <a:schemeClr val="tx1">
+                    <a:lumMod val="75000"/>
+                  </a:schemeClr>
+                </a:solidFill>
+              </a:rPr>
+              <a:t>cooperation play </a:t>
+            </a:r>
+            <a:r>
+              <a:rPr lang="en-GB" sz="3000" dirty="0">
+                <a:solidFill>
+                  <a:schemeClr val="tx1">
+                    <a:lumMod val="75000"/>
+                  </a:schemeClr>
+                </a:solidFill>
+              </a:rPr>
+              <a:t>distinct roles. Communication made hidden information available and was associated with more correct decisions, but also with greater computational effort. Cooperation, by contrast, was associated with lower token usage, suggesting that references to others’ contributions may help agents work more efficiently with already available information. Overall, LLM-based teams benefit less from unrestricted access to information than from a compact, structured representation of what the group knows, believes, and still needs to resolve. Context management is therefore a central design problem for LLM-based multi-agent systems: effective collaboration depends not on providing all available information, but on presenting the most relevant information in a usable form.</a:t>
+            </a:r>
+          </a:p>
+        </p:txBody>
+      </p:sp>
+      <p:sp>
+        <p:nvSpPr>
+          <p:cNvPr id="51" name="TextBox 50">
+            <a:extLst>
+              <a:ext uri="{FF2B5EF4-FFF2-40B4-BE49-F238E27FC236}">
+                <a16:creationId xmlns:a16="http://schemas.microsoft.com/office/drawing/2014/main" id="{9E7EEF27-ABD7-3337-2B0F-BD1D51DE7FBF}"/>
+              </a:ext>
+            </a:extLst>
+          </p:cNvPr>
+          <p:cNvSpPr txBox="1"/>
+          <p:nvPr/>
+        </p:nvSpPr>
+        <p:spPr>
+          <a:xfrm>
+            <a:off x="14526444" y="19128559"/>
+            <a:ext cx="14400000" cy="369332"/>
+          </a:xfrm>
+          <a:prstGeom prst="rect">
+            <a:avLst/>
+          </a:prstGeom>
+          <a:noFill/>
+        </p:spPr>
+        <p:txBody>
+          <a:bodyPr wrap="square" lIns="0" tIns="0" rIns="0" bIns="0" rtlCol="0">
+            <a:spAutoFit/>
+          </a:bodyPr>
+          <a:lstStyle/>
+          <a:p>
+            <a:r>
+              <a:rPr lang="en-DE" sz="2400" i="1" dirty="0">
+                <a:solidFill>
+                  <a:schemeClr val="tx1">
+                    <a:lumMod val="75000"/>
+                  </a:schemeClr>
+                </a:solidFill>
+              </a:rPr>
+              <a:t>Fig. 2: </a:t>
+            </a:r>
+            <a:r>
+              <a:rPr lang="en-GB" sz="2400" i="1" dirty="0">
+                <a:solidFill>
+                  <a:schemeClr val="tx1">
+                    <a:lumMod val="75000"/>
+                  </a:schemeClr>
+                </a:solidFill>
+              </a:rPr>
+              <a:t>Conceptual research model and hypothesized relationships</a:t>
+            </a:r>
+            <a:endParaRPr lang="en-DE" sz="2400" i="1" dirty="0">
+              <a:solidFill>
+                <a:schemeClr val="tx1">
+                  <a:lumMod val="75000"/>
+                </a:schemeClr>
+              </a:solidFill>
+            </a:endParaRPr>
+          </a:p>
+        </p:txBody>
+      </p:sp>
+      <p:sp>
+        <p:nvSpPr>
+          <p:cNvPr id="52" name="TextBox 51">
+            <a:extLst>
+              <a:ext uri="{FF2B5EF4-FFF2-40B4-BE49-F238E27FC236}">
+                <a16:creationId xmlns:a16="http://schemas.microsoft.com/office/drawing/2014/main" id="{92EE2DCD-6885-258E-5363-2CDC62DEA07F}"/>
+              </a:ext>
+            </a:extLst>
+          </p:cNvPr>
+          <p:cNvSpPr txBox="1"/>
+          <p:nvPr/>
+        </p:nvSpPr>
+        <p:spPr>
+          <a:xfrm>
+            <a:off x="977954" y="39221391"/>
+            <a:ext cx="8471844" cy="369332"/>
+          </a:xfrm>
+          <a:prstGeom prst="rect">
+            <a:avLst/>
+          </a:prstGeom>
+          <a:noFill/>
+        </p:spPr>
+        <p:txBody>
+          <a:bodyPr wrap="square" lIns="0" tIns="0" rIns="0" bIns="0" rtlCol="0">
+            <a:spAutoFit/>
+          </a:bodyPr>
+          <a:lstStyle/>
+          <a:p>
+            <a:r>
+              <a:rPr lang="en-DE" sz="2400" i="1" dirty="0">
+                <a:solidFill>
+                  <a:schemeClr val="tx1">
+                    <a:lumMod val="75000"/>
+                  </a:schemeClr>
+                </a:solidFill>
+              </a:rPr>
+              <a:t>Fig. 3: </a:t>
+            </a:r>
+            <a:r>
+              <a:rPr lang="en-GB" sz="2400" i="1" dirty="0">
+                <a:solidFill>
+                  <a:schemeClr val="tx1">
+                    <a:lumMod val="75000"/>
+                  </a:schemeClr>
+                </a:solidFill>
+              </a:rPr>
+              <a:t>Correct-decision rates across experimental conditions</a:t>
+            </a:r>
+            <a:endParaRPr lang="en-DE" sz="2400" i="1" dirty="0">
+              <a:solidFill>
+                <a:schemeClr val="tx1">
+                  <a:lumMod val="75000"/>
+                </a:schemeClr>
+              </a:solidFill>
+            </a:endParaRPr>
+          </a:p>
+        </p:txBody>
+      </p:sp>
+      <p:sp>
+        <p:nvSpPr>
+          <p:cNvPr id="53" name="TextBox 52">
+            <a:extLst>
+              <a:ext uri="{FF2B5EF4-FFF2-40B4-BE49-F238E27FC236}">
+                <a16:creationId xmlns:a16="http://schemas.microsoft.com/office/drawing/2014/main" id="{AF27CCA3-9B03-BE92-ABEB-F0F574BA736E}"/>
+              </a:ext>
+            </a:extLst>
+          </p:cNvPr>
+          <p:cNvSpPr txBox="1"/>
+          <p:nvPr/>
+        </p:nvSpPr>
+        <p:spPr>
+          <a:xfrm>
+            <a:off x="9864717" y="39221391"/>
+            <a:ext cx="8471844" cy="369332"/>
+          </a:xfrm>
+          <a:prstGeom prst="rect">
+            <a:avLst/>
+          </a:prstGeom>
+          <a:noFill/>
+        </p:spPr>
+        <p:txBody>
+          <a:bodyPr wrap="square" lIns="0" tIns="0" rIns="0" bIns="0" rtlCol="0">
+            <a:spAutoFit/>
+          </a:bodyPr>
+          <a:lstStyle/>
+          <a:p>
+            <a:r>
+              <a:rPr lang="en-DE" sz="2400" i="1" dirty="0">
+                <a:solidFill>
+                  <a:schemeClr val="tx1">
+                    <a:lumMod val="75000"/>
+                  </a:schemeClr>
+                </a:solidFill>
+              </a:rPr>
+              <a:t>Fig. 4:  </a:t>
+            </a:r>
+            <a:r>
+              <a:rPr lang="en-GB" sz="2400" i="1" dirty="0">
+                <a:solidFill>
+                  <a:schemeClr val="tx1">
+                    <a:lumMod val="75000"/>
+                  </a:schemeClr>
+                </a:solidFill>
+              </a:rPr>
+              <a:t>Weighted token usage across experimental conditions</a:t>
+            </a:r>
+            <a:endParaRPr lang="en-DE" sz="2400" i="1" dirty="0">
+              <a:solidFill>
+                <a:schemeClr val="tx1">
+                  <a:lumMod val="75000"/>
+                </a:schemeClr>
+              </a:solidFill>
+            </a:endParaRPr>
+          </a:p>
+        </p:txBody>
+      </p:sp>
+      <p:sp>
+        <p:nvSpPr>
+          <p:cNvPr id="54" name="TextBox 53">
+            <a:extLst>
+              <a:ext uri="{FF2B5EF4-FFF2-40B4-BE49-F238E27FC236}">
+                <a16:creationId xmlns:a16="http://schemas.microsoft.com/office/drawing/2014/main" id="{2E1E1C97-9FC4-3431-31F4-80D18D0E3EE5}"/>
+              </a:ext>
+            </a:extLst>
+          </p:cNvPr>
+          <p:cNvSpPr txBox="1"/>
+          <p:nvPr/>
+        </p:nvSpPr>
+        <p:spPr>
+          <a:xfrm>
+            <a:off x="18751480" y="39221391"/>
+            <a:ext cx="8471844" cy="369332"/>
+          </a:xfrm>
+          <a:prstGeom prst="rect">
+            <a:avLst/>
+          </a:prstGeom>
+          <a:noFill/>
+        </p:spPr>
+        <p:txBody>
+          <a:bodyPr wrap="square" lIns="0" tIns="0" rIns="0" bIns="0" rtlCol="0">
+            <a:spAutoFit/>
+          </a:bodyPr>
+          <a:lstStyle/>
+          <a:p>
+            <a:r>
+              <a:rPr lang="en-DE" sz="2400" i="1" dirty="0">
+                <a:solidFill>
+                  <a:schemeClr val="tx1">
+                    <a:lumMod val="75000"/>
+                  </a:schemeClr>
+                </a:solidFill>
+              </a:rPr>
+              <a:t>Tab. 1: </a:t>
+            </a:r>
+            <a:r>
+              <a:rPr lang="en-GB" sz="2400" i="1" dirty="0">
+                <a:solidFill>
+                  <a:schemeClr val="tx1">
+                    <a:lumMod val="75000"/>
+                  </a:schemeClr>
+                </a:solidFill>
+              </a:rPr>
+              <a:t>Regression results</a:t>
+            </a:r>
+            <a:endParaRPr lang="en-DE" sz="2400" i="1" dirty="0">
+              <a:solidFill>
+                <a:schemeClr val="tx1">
+                  <a:lumMod val="75000"/>
+                </a:schemeClr>
+              </a:solidFill>
+            </a:endParaRPr>
+          </a:p>
+        </p:txBody>
+      </p:sp>
+      <p:sp>
+        <p:nvSpPr>
+          <p:cNvPr id="78" name="TextBox 77">
+            <a:extLst>
+              <a:ext uri="{FF2B5EF4-FFF2-40B4-BE49-F238E27FC236}">
+                <a16:creationId xmlns:a16="http://schemas.microsoft.com/office/drawing/2014/main" id="{B517C234-520F-C026-42F5-68A8DBF58DC0}"/>
+              </a:ext>
+            </a:extLst>
+          </p:cNvPr>
+          <p:cNvSpPr txBox="1"/>
+          <p:nvPr/>
+        </p:nvSpPr>
+        <p:spPr>
+          <a:xfrm>
+            <a:off x="979486" y="26150933"/>
+            <a:ext cx="13148900" cy="383598"/>
+          </a:xfrm>
+          <a:prstGeom prst="rect">
+            <a:avLst/>
+          </a:prstGeom>
+          <a:noFill/>
+        </p:spPr>
+        <p:txBody>
+          <a:bodyPr wrap="square" lIns="0" tIns="0" rIns="0" bIns="0" rtlCol="0">
+            <a:spAutoFit/>
+          </a:bodyPr>
+          <a:lstStyle/>
+          <a:p>
+            <a:r>
+              <a:rPr lang="en-DE" sz="2400" i="1" dirty="0">
+                <a:solidFill>
+                  <a:schemeClr val="tx1">
+                    <a:lumMod val="75000"/>
+                  </a:schemeClr>
+                </a:solidFill>
+              </a:rPr>
+              <a:t>Fig. 1:  </a:t>
+            </a:r>
+            <a:r>
+              <a:rPr lang="en-GB" sz="2400" i="1" dirty="0">
+                <a:solidFill>
+                  <a:schemeClr val="tx1">
+                    <a:lumMod val="75000"/>
+                  </a:schemeClr>
+                </a:solidFill>
+              </a:rPr>
+              <a:t>Mapping the human team cognition perspective onto LLM-based MAS</a:t>
+            </a:r>
+            <a:endParaRPr lang="en-DE" sz="2400" i="1" dirty="0">
+              <a:solidFill>
+                <a:schemeClr val="tx1">
+                  <a:lumMod val="75000"/>
+                </a:schemeClr>
+              </a:solidFill>
+            </a:endParaRPr>
+          </a:p>
+        </p:txBody>
+      </p:sp>
+      <p:sp>
+        <p:nvSpPr>
+          <p:cNvPr id="79" name="TextBox 78">
+            <a:extLst>
+              <a:ext uri="{FF2B5EF4-FFF2-40B4-BE49-F238E27FC236}">
+                <a16:creationId xmlns:a16="http://schemas.microsoft.com/office/drawing/2014/main" id="{D9DE1A91-1EB2-17D4-009A-F564AA6BF4DE}"/>
+              </a:ext>
+            </a:extLst>
+          </p:cNvPr>
+          <p:cNvSpPr txBox="1"/>
+          <p:nvPr/>
+        </p:nvSpPr>
+        <p:spPr>
+          <a:xfrm>
+            <a:off x="14526444" y="11129354"/>
+            <a:ext cx="15218459" cy="3693319"/>
+          </a:xfrm>
+          <a:prstGeom prst="rect">
+            <a:avLst/>
+          </a:prstGeom>
+          <a:noFill/>
+        </p:spPr>
+        <p:txBody>
+          <a:bodyPr wrap="square" lIns="0" tIns="0" rIns="0" bIns="0" rtlCol="0">
+            <a:spAutoFit/>
+          </a:bodyPr>
+          <a:lstStyle/>
+          <a:p>
+            <a:pPr algn="just"/>
+            <a:r>
+              <a:rPr lang="en-GB" sz="3000" dirty="0">
+                <a:solidFill>
+                  <a:schemeClr val="tx1">
+                    <a:lumMod val="75000"/>
+                  </a:schemeClr>
+                </a:solidFill>
+              </a:rPr>
+              <a:t>Accordingly, the structured memory is expected to improve communication quality (H1a) and cooperation quality (H1b). Within the structured memory conditions, moderate discussion context transparency is expected to outperform low transparency because agents can better trace and ground previous contributions (H2a, H2b). Moderate transparency is also expected to outperform high transparency because excessive context may reduce the salience of decision-relevant information (H3a, H3b). Finally, higher communication and cooperation quality are expected to improve both efficiency and effectiveness (H4a–H5b).</a:t>
+            </a:r>
+          </a:p>
+        </p:txBody>
+      </p:sp>
       <p:pic>
         <p:nvPicPr>
-          <p:cNvPr id="29" name="Picture 28">
+          <p:cNvPr id="4" name="Picture 3">
             <a:extLst>
               <a:ext uri="{FF2B5EF4-FFF2-40B4-BE49-F238E27FC236}">
-                <a16:creationId xmlns:a16="http://schemas.microsoft.com/office/drawing/2014/main" id="{6AD95C22-67FB-1304-D442-068A9068C489}"/>
+                <a16:creationId xmlns:a16="http://schemas.microsoft.com/office/drawing/2014/main" id="{05D8A3FB-5571-02BF-90CE-59D3B10D8B31}"/>
               </a:ext>
             </a:extLst>
           </p:cNvPr>
@@ -7389,108 +7822,26 @@
         </p:nvPicPr>
         <p:blipFill>
           <a:blip r:embed="rId3"/>
-          <a:srcRect b="4613"/>
           <a:stretch>
             <a:fillRect/>
           </a:stretch>
         </p:blipFill>
         <p:spPr>
           <a:xfrm>
-            <a:off x="18601188" y="31789667"/>
-            <a:ext cx="11143715" cy="7200000"/>
+            <a:off x="978720" y="20814764"/>
+            <a:ext cx="13251600" cy="5432155"/>
           </a:xfrm>
           <a:prstGeom prst="rect">
             <a:avLst/>
           </a:prstGeom>
         </p:spPr>
       </p:pic>
-      <p:sp>
-        <p:nvSpPr>
-          <p:cNvPr id="30" name="TextBox 29">
+      <p:pic>
+        <p:nvPicPr>
+          <p:cNvPr id="7" name="Picture 6">
             <a:extLst>
               <a:ext uri="{FF2B5EF4-FFF2-40B4-BE49-F238E27FC236}">
-                <a16:creationId xmlns:a16="http://schemas.microsoft.com/office/drawing/2014/main" id="{A4DAE3DE-44F3-E8CE-612F-BC9D0AFA3EA6}"/>
-              </a:ext>
-            </a:extLst>
-          </p:cNvPr>
-          <p:cNvSpPr txBox="1"/>
-          <p:nvPr/>
-        </p:nvSpPr>
-        <p:spPr>
-          <a:xfrm>
-            <a:off x="14526443" y="20892214"/>
-            <a:ext cx="17446626" cy="830997"/>
-          </a:xfrm>
-          <a:prstGeom prst="rect">
-            <a:avLst/>
-          </a:prstGeom>
-          <a:noFill/>
-        </p:spPr>
-        <p:txBody>
-          <a:bodyPr wrap="square" lIns="0" tIns="0" rIns="0" bIns="0" rtlCol="0">
-            <a:spAutoFit/>
-          </a:bodyPr>
-          <a:lstStyle/>
-          <a:p>
-            <a:r>
-              <a:rPr lang="en-DE" sz="5400" b="1" dirty="0">
-                <a:solidFill>
-                  <a:schemeClr val="tx2"/>
-                </a:solidFill>
-              </a:rPr>
-              <a:t>III. Methodology</a:t>
-            </a:r>
-          </a:p>
-        </p:txBody>
-      </p:sp>
-      <p:sp>
-        <p:nvSpPr>
-          <p:cNvPr id="34" name="TextBox 33">
-            <a:extLst>
-              <a:ext uri="{FF2B5EF4-FFF2-40B4-BE49-F238E27FC236}">
-                <a16:creationId xmlns:a16="http://schemas.microsoft.com/office/drawing/2014/main" id="{BCB0C2AC-AE2B-E4AC-4D1F-9AC9680D5E1B}"/>
-              </a:ext>
-            </a:extLst>
-          </p:cNvPr>
-          <p:cNvSpPr txBox="1"/>
-          <p:nvPr/>
-        </p:nvSpPr>
-        <p:spPr>
-          <a:xfrm>
-            <a:off x="979487" y="27895818"/>
-            <a:ext cx="28765417" cy="3693319"/>
-          </a:xfrm>
-          <a:prstGeom prst="rect">
-            <a:avLst/>
-          </a:prstGeom>
-          <a:noFill/>
-        </p:spPr>
-        <p:txBody>
-          <a:bodyPr wrap="square" lIns="0" tIns="0" rIns="0" bIns="0" rtlCol="0">
-            <a:spAutoFit/>
-          </a:bodyPr>
-          <a:lstStyle/>
-          <a:p>
-            <a:pPr algn="just"/>
-            <a:r>
-              <a:rPr lang="en-GB" sz="3000" dirty="0">
-                <a:solidFill>
-                  <a:schemeClr val="tx1">
-                    <a:lumMod val="75000"/>
-                  </a:schemeClr>
-                </a:solidFill>
-              </a:rPr>
-              <a:t>Across 800 simulations, structured memory improved collective LLM-agent decision-making, but its benefits depended on the surrounding context. Communication improved in all structured-memory conditions, whereas cooperation improved only when agents received limited additional discussion history. The strongest overall outcomes therefore emerged when a structured shared representation was paired with a selective rather than extensive raw context. The performance results support this conclusion. Limited context produced the most accurate decisions, while high transparency combined comparatively poor effectiveness with the greatest token usage. More prior discussion history was therefore not automatically beneficial and may have reduced the salience of decision-relevant information. The regression results further show that communication and cooperation fulfil distinct roles. Communication increased the likelihood of a correct decision but required greater computational effort. Cooperation, in contrast, was associated with lower token usage and marginally higher decision effectiveness. Overall, the findings suggest that LLM-based teams benefit less from maximising available history than from maintaining a selective, structured, and usable representation of shared knowledge.</a:t>
-            </a:r>
-          </a:p>
-        </p:txBody>
-      </p:sp>
-      <p:pic>
-        <p:nvPicPr>
-          <p:cNvPr id="44" name="Picture 43">
-            <a:extLst>
-              <a:ext uri="{FF2B5EF4-FFF2-40B4-BE49-F238E27FC236}">
-                <a16:creationId xmlns:a16="http://schemas.microsoft.com/office/drawing/2014/main" id="{1BFC0854-F93E-092F-BFE8-EDFEBAF355BC}"/>
+                <a16:creationId xmlns:a16="http://schemas.microsoft.com/office/drawing/2014/main" id="{4B9368A7-8425-CB1B-8D2F-4A2A21BD1ACD}"/>
               </a:ext>
             </a:extLst>
           </p:cNvPr>
@@ -7501,15 +7852,14 @@
         </p:nvPicPr>
         <p:blipFill>
           <a:blip r:embed="rId4"/>
-          <a:srcRect l="3110" t="6598"/>
           <a:stretch>
             <a:fillRect/>
           </a:stretch>
         </p:blipFill>
         <p:spPr>
           <a:xfrm>
-            <a:off x="979486" y="31789667"/>
-            <a:ext cx="8573013" cy="7200001"/>
+            <a:off x="14527073" y="14991073"/>
+            <a:ext cx="15217200" cy="4093831"/>
           </a:xfrm>
           <a:prstGeom prst="rect">
             <a:avLst/>
@@ -7518,10 +7868,10 @@
       </p:pic>
       <p:pic>
         <p:nvPicPr>
-          <p:cNvPr id="46" name="Picture 45">
+          <p:cNvPr id="15" name="Picture 14">
             <a:extLst>
               <a:ext uri="{FF2B5EF4-FFF2-40B4-BE49-F238E27FC236}">
-                <a16:creationId xmlns:a16="http://schemas.microsoft.com/office/drawing/2014/main" id="{66593556-D031-55E1-4FD6-7F3A1CFC0E1B}"/>
+                <a16:creationId xmlns:a16="http://schemas.microsoft.com/office/drawing/2014/main" id="{8E6C2AF3-5510-A5BE-D672-54391EB47E07}"/>
               </a:ext>
             </a:extLst>
           </p:cNvPr>
@@ -7532,359 +7882,26 @@
         </p:nvPicPr>
         <p:blipFill>
           <a:blip r:embed="rId5"/>
-          <a:srcRect l="3110" t="6598"/>
           <a:stretch>
             <a:fillRect/>
           </a:stretch>
         </p:blipFill>
         <p:spPr>
           <a:xfrm>
-            <a:off x="9702800" y="31789667"/>
-            <a:ext cx="8573013" cy="7200000"/>
+            <a:off x="977954" y="31753709"/>
+            <a:ext cx="8571600" cy="7467682"/>
           </a:xfrm>
           <a:prstGeom prst="rect">
             <a:avLst/>
           </a:prstGeom>
         </p:spPr>
       </p:pic>
-      <p:sp>
-        <p:nvSpPr>
-          <p:cNvPr id="51" name="TextBox 50">
+      <p:pic>
+        <p:nvPicPr>
+          <p:cNvPr id="20" name="Picture 19">
             <a:extLst>
               <a:ext uri="{FF2B5EF4-FFF2-40B4-BE49-F238E27FC236}">
-                <a16:creationId xmlns:a16="http://schemas.microsoft.com/office/drawing/2014/main" id="{9E7EEF27-ABD7-3337-2B0F-BD1D51DE7FBF}"/>
-              </a:ext>
-            </a:extLst>
-          </p:cNvPr>
-          <p:cNvSpPr txBox="1"/>
-          <p:nvPr/>
-        </p:nvSpPr>
-        <p:spPr>
-          <a:xfrm>
-            <a:off x="14526444" y="20306680"/>
-            <a:ext cx="14400000" cy="369332"/>
-          </a:xfrm>
-          <a:prstGeom prst="rect">
-            <a:avLst/>
-          </a:prstGeom>
-          <a:noFill/>
-        </p:spPr>
-        <p:txBody>
-          <a:bodyPr wrap="square" lIns="0" tIns="0" rIns="0" bIns="0" rtlCol="0">
-            <a:spAutoFit/>
-          </a:bodyPr>
-          <a:lstStyle/>
-          <a:p>
-            <a:r>
-              <a:rPr lang="en-DE" sz="2400" i="1" dirty="0">
-                <a:solidFill>
-                  <a:schemeClr val="tx1">
-                    <a:lumMod val="75000"/>
-                  </a:schemeClr>
-                </a:solidFill>
-              </a:rPr>
-              <a:t>Fig. 2: </a:t>
-            </a:r>
-            <a:r>
-              <a:rPr lang="en-GB" sz="2400" i="1" dirty="0">
-                <a:solidFill>
-                  <a:schemeClr val="tx1">
-                    <a:lumMod val="75000"/>
-                  </a:schemeClr>
-                </a:solidFill>
-              </a:rPr>
-              <a:t>Conceptual research model and hypothesized relationships</a:t>
-            </a:r>
-            <a:endParaRPr lang="en-DE" sz="2400" i="1" dirty="0">
-              <a:solidFill>
-                <a:schemeClr val="tx1">
-                  <a:lumMod val="75000"/>
-                </a:schemeClr>
-              </a:solidFill>
-            </a:endParaRPr>
-          </a:p>
-        </p:txBody>
-      </p:sp>
-      <p:sp>
-        <p:nvSpPr>
-          <p:cNvPr id="52" name="TextBox 51">
-            <a:extLst>
-              <a:ext uri="{FF2B5EF4-FFF2-40B4-BE49-F238E27FC236}">
-                <a16:creationId xmlns:a16="http://schemas.microsoft.com/office/drawing/2014/main" id="{92EE2DCD-6885-258E-5363-2CDC62DEA07F}"/>
-              </a:ext>
-            </a:extLst>
-          </p:cNvPr>
-          <p:cNvSpPr txBox="1"/>
-          <p:nvPr/>
-        </p:nvSpPr>
-        <p:spPr>
-          <a:xfrm>
-            <a:off x="979486" y="39221391"/>
-            <a:ext cx="8471844" cy="369332"/>
-          </a:xfrm>
-          <a:prstGeom prst="rect">
-            <a:avLst/>
-          </a:prstGeom>
-          <a:noFill/>
-        </p:spPr>
-        <p:txBody>
-          <a:bodyPr wrap="square" lIns="0" tIns="0" rIns="0" bIns="0" rtlCol="0">
-            <a:spAutoFit/>
-          </a:bodyPr>
-          <a:lstStyle/>
-          <a:p>
-            <a:r>
-              <a:rPr lang="en-DE" sz="2400" i="1" dirty="0">
-                <a:solidFill>
-                  <a:schemeClr val="tx1">
-                    <a:lumMod val="75000"/>
-                  </a:schemeClr>
-                </a:solidFill>
-              </a:rPr>
-              <a:t>Fig. 2: </a:t>
-            </a:r>
-            <a:r>
-              <a:rPr lang="en-GB" sz="2400" i="1" dirty="0">
-                <a:solidFill>
-                  <a:schemeClr val="tx1">
-                    <a:lumMod val="75000"/>
-                  </a:schemeClr>
-                </a:solidFill>
-              </a:rPr>
-              <a:t>Correct-decision rates across experimental conditions</a:t>
-            </a:r>
-            <a:endParaRPr lang="en-DE" sz="2400" i="1" dirty="0">
-              <a:solidFill>
-                <a:schemeClr val="tx1">
-                  <a:lumMod val="75000"/>
-                </a:schemeClr>
-              </a:solidFill>
-            </a:endParaRPr>
-          </a:p>
-        </p:txBody>
-      </p:sp>
-      <p:sp>
-        <p:nvSpPr>
-          <p:cNvPr id="53" name="TextBox 52">
-            <a:extLst>
-              <a:ext uri="{FF2B5EF4-FFF2-40B4-BE49-F238E27FC236}">
-                <a16:creationId xmlns:a16="http://schemas.microsoft.com/office/drawing/2014/main" id="{AF27CCA3-9B03-BE92-ABEB-F0F574BA736E}"/>
-              </a:ext>
-            </a:extLst>
-          </p:cNvPr>
-          <p:cNvSpPr txBox="1"/>
-          <p:nvPr/>
-        </p:nvSpPr>
-        <p:spPr>
-          <a:xfrm>
-            <a:off x="9702800" y="39221391"/>
-            <a:ext cx="8471844" cy="369332"/>
-          </a:xfrm>
-          <a:prstGeom prst="rect">
-            <a:avLst/>
-          </a:prstGeom>
-          <a:noFill/>
-        </p:spPr>
-        <p:txBody>
-          <a:bodyPr wrap="square" lIns="0" tIns="0" rIns="0" bIns="0" rtlCol="0">
-            <a:spAutoFit/>
-          </a:bodyPr>
-          <a:lstStyle/>
-          <a:p>
-            <a:r>
-              <a:rPr lang="en-DE" sz="2400" i="1" dirty="0">
-                <a:solidFill>
-                  <a:schemeClr val="tx1">
-                    <a:lumMod val="75000"/>
-                  </a:schemeClr>
-                </a:solidFill>
-              </a:rPr>
-              <a:t>Fig. 3:  </a:t>
-            </a:r>
-            <a:r>
-              <a:rPr lang="en-GB" sz="2400" i="1" dirty="0">
-                <a:solidFill>
-                  <a:schemeClr val="tx1">
-                    <a:lumMod val="75000"/>
-                  </a:schemeClr>
-                </a:solidFill>
-              </a:rPr>
-              <a:t>Weighted token usage across experimental conditions</a:t>
-            </a:r>
-            <a:endParaRPr lang="en-DE" sz="2400" i="1" dirty="0">
-              <a:solidFill>
-                <a:schemeClr val="tx1">
-                  <a:lumMod val="75000"/>
-                </a:schemeClr>
-              </a:solidFill>
-            </a:endParaRPr>
-          </a:p>
-        </p:txBody>
-      </p:sp>
-      <p:sp>
-        <p:nvSpPr>
-          <p:cNvPr id="54" name="TextBox 53">
-            <a:extLst>
-              <a:ext uri="{FF2B5EF4-FFF2-40B4-BE49-F238E27FC236}">
-                <a16:creationId xmlns:a16="http://schemas.microsoft.com/office/drawing/2014/main" id="{2E1E1C97-9FC4-3431-31F4-80D18D0E3EE5}"/>
-              </a:ext>
-            </a:extLst>
-          </p:cNvPr>
-          <p:cNvSpPr txBox="1"/>
-          <p:nvPr/>
-        </p:nvSpPr>
-        <p:spPr>
-          <a:xfrm>
-            <a:off x="18601188" y="39221391"/>
-            <a:ext cx="8471844" cy="369332"/>
-          </a:xfrm>
-          <a:prstGeom prst="rect">
-            <a:avLst/>
-          </a:prstGeom>
-          <a:noFill/>
-        </p:spPr>
-        <p:txBody>
-          <a:bodyPr wrap="square" lIns="0" tIns="0" rIns="0" bIns="0" rtlCol="0">
-            <a:spAutoFit/>
-          </a:bodyPr>
-          <a:lstStyle/>
-          <a:p>
-            <a:r>
-              <a:rPr lang="en-DE" sz="2400" i="1" dirty="0">
-                <a:solidFill>
-                  <a:schemeClr val="tx1">
-                    <a:lumMod val="75000"/>
-                  </a:schemeClr>
-                </a:solidFill>
-              </a:rPr>
-              <a:t>Table 1: </a:t>
-            </a:r>
-            <a:r>
-              <a:rPr lang="en-GB" sz="2400" i="1" dirty="0">
-                <a:solidFill>
-                  <a:schemeClr val="tx1">
-                    <a:lumMod val="75000"/>
-                  </a:schemeClr>
-                </a:solidFill>
-              </a:rPr>
-              <a:t>Regression results</a:t>
-            </a:r>
-            <a:endParaRPr lang="en-DE" sz="2400" i="1" dirty="0">
-              <a:solidFill>
-                <a:schemeClr val="tx1">
-                  <a:lumMod val="75000"/>
-                </a:schemeClr>
-              </a:solidFill>
-            </a:endParaRPr>
-          </a:p>
-        </p:txBody>
-      </p:sp>
-      <p:sp>
-        <p:nvSpPr>
-          <p:cNvPr id="78" name="TextBox 77">
-            <a:extLst>
-              <a:ext uri="{FF2B5EF4-FFF2-40B4-BE49-F238E27FC236}">
-                <a16:creationId xmlns:a16="http://schemas.microsoft.com/office/drawing/2014/main" id="{B517C234-520F-C026-42F5-68A8DBF58DC0}"/>
-              </a:ext>
-            </a:extLst>
-          </p:cNvPr>
-          <p:cNvSpPr txBox="1"/>
-          <p:nvPr/>
-        </p:nvSpPr>
-        <p:spPr>
-          <a:xfrm>
-            <a:off x="979486" y="26358880"/>
-            <a:ext cx="13148900" cy="383598"/>
-          </a:xfrm>
-          <a:prstGeom prst="rect">
-            <a:avLst/>
-          </a:prstGeom>
-          <a:noFill/>
-        </p:spPr>
-        <p:txBody>
-          <a:bodyPr wrap="square" lIns="0" tIns="0" rIns="0" bIns="0" rtlCol="0">
-            <a:spAutoFit/>
-          </a:bodyPr>
-          <a:lstStyle/>
-          <a:p>
-            <a:r>
-              <a:rPr lang="en-DE" sz="2400" i="1" dirty="0">
-                <a:solidFill>
-                  <a:schemeClr val="tx1">
-                    <a:lumMod val="75000"/>
-                  </a:schemeClr>
-                </a:solidFill>
-              </a:rPr>
-              <a:t>Fig. 1:  </a:t>
-            </a:r>
-            <a:r>
-              <a:rPr lang="en-GB" sz="2400" i="1" dirty="0">
-                <a:solidFill>
-                  <a:schemeClr val="tx1">
-                    <a:lumMod val="75000"/>
-                  </a:schemeClr>
-                </a:solidFill>
-              </a:rPr>
-              <a:t>Transfer from human team cognition theory to multi-agent systems</a:t>
-            </a:r>
-            <a:endParaRPr lang="en-DE" sz="2400" i="1" dirty="0">
-              <a:solidFill>
-                <a:schemeClr val="tx1">
-                  <a:lumMod val="75000"/>
-                </a:schemeClr>
-              </a:solidFill>
-            </a:endParaRPr>
-          </a:p>
-        </p:txBody>
-      </p:sp>
-      <p:sp>
-        <p:nvSpPr>
-          <p:cNvPr id="79" name="TextBox 78">
-            <a:extLst>
-              <a:ext uri="{FF2B5EF4-FFF2-40B4-BE49-F238E27FC236}">
-                <a16:creationId xmlns:a16="http://schemas.microsoft.com/office/drawing/2014/main" id="{D9DE1A91-1EB2-17D4-009A-F564AA6BF4DE}"/>
-              </a:ext>
-            </a:extLst>
-          </p:cNvPr>
-          <p:cNvSpPr txBox="1"/>
-          <p:nvPr/>
-        </p:nvSpPr>
-        <p:spPr>
-          <a:xfrm>
-            <a:off x="14526444" y="11129354"/>
-            <a:ext cx="15218459" cy="5078313"/>
-          </a:xfrm>
-          <a:prstGeom prst="rect">
-            <a:avLst/>
-          </a:prstGeom>
-          <a:noFill/>
-        </p:spPr>
-        <p:txBody>
-          <a:bodyPr wrap="square" lIns="0" tIns="0" rIns="0" bIns="0" rtlCol="0">
-            <a:spAutoFit/>
-          </a:bodyPr>
-          <a:lstStyle/>
-          <a:p>
-            <a:pPr algn="just"/>
-            <a:r>
-              <a:rPr lang="en-GB" sz="3000" dirty="0">
-                <a:solidFill>
-                  <a:schemeClr val="tx1">
-                    <a:lumMod val="75000"/>
-                  </a:schemeClr>
-                </a:solidFill>
-              </a:rPr>
-              <a:t>Accordingly, LLM-based multi-agent systems employing the structured memory mechanism are expected to exhibit higher communication quality (H1a) and cooperation quality (H1b) than transcript-only baseline systems. Within the structured-memory conditions, moderate discussion-context transparency is expected to improve communication (H2a) and cooperation (H2b) relative to low transparency because agents can trace and ground prior contributions in the discussion history. Moderate transparency is also expected to outperform high transparency in communication (H3a) and cooperation (H3b), as excessive context may reduce the salience of decision-relevant information. Finally, higher communication quality is expected to improve computational efficiency (H4a) and decision effectiveness (H4b), while higher cooperation quality is expected to improve computational efficiency (H5a) and decision effectiveness (H5b).</a:t>
-            </a:r>
-          </a:p>
-        </p:txBody>
-      </p:sp>
-      <p:pic>
-        <p:nvPicPr>
-          <p:cNvPr id="82" name="Picture 81">
-            <a:extLst>
-              <a:ext uri="{FF2B5EF4-FFF2-40B4-BE49-F238E27FC236}">
-                <a16:creationId xmlns:a16="http://schemas.microsoft.com/office/drawing/2014/main" id="{84B278B7-588E-8D06-7318-C0EDB9B1C358}"/>
+                <a16:creationId xmlns:a16="http://schemas.microsoft.com/office/drawing/2014/main" id="{E77C6955-74E2-A24B-0B0B-B28A2D19F93E}"/>
               </a:ext>
             </a:extLst>
           </p:cNvPr>
@@ -7895,15 +7912,14 @@
         </p:nvPicPr>
         <p:blipFill>
           <a:blip r:embed="rId6"/>
-          <a:srcRect l="628" t="3560" r="737" b="3432"/>
           <a:stretch>
             <a:fillRect/>
           </a:stretch>
         </p:blipFill>
         <p:spPr>
           <a:xfrm>
-            <a:off x="979486" y="21224484"/>
-            <a:ext cx="13141418" cy="5079600"/>
+            <a:off x="9864717" y="31753709"/>
+            <a:ext cx="8571600" cy="7467682"/>
           </a:xfrm>
           <a:prstGeom prst="rect">
             <a:avLst/>
@@ -7912,10 +7928,10 @@
       </p:pic>
       <p:pic>
         <p:nvPicPr>
-          <p:cNvPr id="84" name="Picture 83">
+          <p:cNvPr id="23" name="Picture 22">
             <a:extLst>
               <a:ext uri="{FF2B5EF4-FFF2-40B4-BE49-F238E27FC236}">
-                <a16:creationId xmlns:a16="http://schemas.microsoft.com/office/drawing/2014/main" id="{2F7626C0-1CF2-A855-60DE-6EC3DEDF5595}"/>
+                <a16:creationId xmlns:a16="http://schemas.microsoft.com/office/drawing/2014/main" id="{809C7978-8B7F-8003-483C-5A88F84BF3D4}"/>
               </a:ext>
             </a:extLst>
           </p:cNvPr>
@@ -7932,14 +7948,52 @@
         </p:blipFill>
         <p:spPr>
           <a:xfrm>
-            <a:off x="14526443" y="16226158"/>
-            <a:ext cx="14626065" cy="3934800"/>
+            <a:off x="18751480" y="31753709"/>
+            <a:ext cx="10992162" cy="7539496"/>
           </a:xfrm>
           <a:prstGeom prst="rect">
             <a:avLst/>
           </a:prstGeom>
         </p:spPr>
       </p:pic>
+      <p:sp>
+        <p:nvSpPr>
+          <p:cNvPr id="26" name="TextBox 25">
+            <a:extLst>
+              <a:ext uri="{FF2B5EF4-FFF2-40B4-BE49-F238E27FC236}">
+                <a16:creationId xmlns:a16="http://schemas.microsoft.com/office/drawing/2014/main" id="{A40660EB-0662-47D0-19B2-4E79D4133EF2}"/>
+              </a:ext>
+            </a:extLst>
+          </p:cNvPr>
+          <p:cNvSpPr txBox="1"/>
+          <p:nvPr/>
+        </p:nvSpPr>
+        <p:spPr>
+          <a:xfrm>
+            <a:off x="30710459" y="34501873"/>
+            <a:ext cx="65" cy="461665"/>
+          </a:xfrm>
+          <a:prstGeom prst="rect">
+            <a:avLst/>
+          </a:prstGeom>
+          <a:noFill/>
+        </p:spPr>
+        <p:txBody>
+          <a:bodyPr wrap="none" lIns="0" tIns="0" rIns="0" bIns="0" rtlCol="0">
+            <a:spAutoFit/>
+          </a:bodyPr>
+          <a:lstStyle/>
+          <a:p>
+            <a:endParaRPr lang="en-DE" sz="3000" dirty="0" err="1">
+              <a:solidFill>
+                <a:schemeClr val="tx1">
+                  <a:lumMod val="75000"/>
+                </a:schemeClr>
+              </a:solidFill>
+            </a:endParaRPr>
+          </a:p>
+        </p:txBody>
+      </p:sp>
     </p:spTree>
     <p:extLst>
       <p:ext uri="{BB962C8B-B14F-4D97-AF65-F5344CB8AC3E}">

</xml_diff>